<commit_message>
Lead the README with the live dashboard and headline results
The repo opened with a paragraph of description and no link to anything
runnable. It now leads with the deployed dashboard, the architecture doc and
the Idea deck, plus a results table so the numbers are visible without
scrolling.

Also corrects the repository URL throughout. The repo was renamed to
`Eco_loop`; GitHub silently redirects GET requests, so the old
`Eco_loop_building_agents` links kept working and the rename went unnoticed -
but a PATCH does not follow that redirect, which is how it surfaced. README
and the deck's artifacts/references slides now use the canonical name, and
the deck was rebuilt so its printed URLs match.

Co-Authored-By: Claude Opus 5 <noreply@anthropic.com>
</commit_message>
<xml_diff>
--- a/deck/Eco-Loop_Building_Agents_Idea.pptx
+++ b/deck/Eco-Loop_Building_Agents_Idea.pptx
@@ -7830,7 +7830,7 @@
                 </a:solidFill>
                 <a:latin typeface="Calibri"/>
               </a:rPr>
-              <a:t>Code   github.com/ayushYadav1107/Eco_loop_building_agents</a:t>
+              <a:t>Code   github.com/ayushYadav1107/Eco_loop</a:t>
             </a:r>
           </a:p>
           <a:p>
@@ -8523,7 +8523,7 @@
                 </a:solidFill>
                 <a:latin typeface="Calibri"/>
               </a:rPr>
-              <a:t>Repository, architecture document and reproducible results — github.com/ayushYadav1107/Eco_loop_building_agents</a:t>
+              <a:t>Repository, architecture document and reproducible results — github.com/ayushYadav1107/Eco_loop</a:t>
             </a:r>
           </a:p>
         </p:txBody>

</xml_diff>